<commit_message>
fix: SVM diagram alignment and add TRACE system architecture
- Fix slide 5 SVM boundary from horizontal to vertical for correct class separation
- Add system architecture diagram (TRACE_SystemArchitecture.png)
- Add create_system_architecture.py script
</commit_message>
<xml_diff>
--- a/presentation/Video2Knowledge_Training.pptx
+++ b/presentation/Video2Knowledge_Training.pptx
@@ -22059,13 +22059,13 @@
         <p:spPr>
           <a:xfrm>
             <a:off x="1188720" y="1188720"/>
-            <a:ext cx="4572000" cy="4114800"/>
+            <a:ext cx="4572000" cy="4389120"/>
           </a:xfrm>
           <a:prstGeom prst="roundRect">
             <a:avLst/>
           </a:prstGeom>
           <a:solidFill>
-            <a:srgbClr val="F0F4F8"/>
+            <a:srgbClr val="002A55"/>
           </a:solidFill>
           <a:ln>
             <a:noFill/>
@@ -22101,7 +22101,7 @@
         </p:nvSpPr>
         <p:spPr>
           <a:xfrm>
-            <a:off x="1371600" y="1280160"/>
+            <a:off x="1371600" y="1234440"/>
             <a:ext cx="4206240" cy="320040"/>
           </a:xfrm>
           <a:prstGeom prst="rect">
@@ -22137,8 +22137,8 @@
         </p:nvSpPr>
         <p:spPr>
           <a:xfrm>
-            <a:off x="1645920" y="2011680"/>
-            <a:ext cx="164592" cy="164592"/>
+            <a:off x="1554480" y="2011680"/>
+            <a:ext cx="182880" cy="182880"/>
           </a:xfrm>
           <a:prstGeom prst="roundRect">
             <a:avLst/>
@@ -22180,8 +22180,8 @@
         </p:nvSpPr>
         <p:spPr>
           <a:xfrm>
-            <a:off x="2103120" y="2468880"/>
-            <a:ext cx="164592" cy="164592"/>
+            <a:off x="1828800" y="2560320"/>
+            <a:ext cx="182880" cy="182880"/>
           </a:xfrm>
           <a:prstGeom prst="roundRect">
             <a:avLst/>
@@ -22223,8 +22223,8 @@
         </p:nvSpPr>
         <p:spPr>
           <a:xfrm>
-            <a:off x="1920240" y="2926080"/>
-            <a:ext cx="164592" cy="164592"/>
+            <a:off x="1645920" y="3108960"/>
+            <a:ext cx="182880" cy="182880"/>
           </a:xfrm>
           <a:prstGeom prst="roundRect">
             <a:avLst/>
@@ -22266,8 +22266,8 @@
         </p:nvSpPr>
         <p:spPr>
           <a:xfrm>
-            <a:off x="2377440" y="2286000"/>
-            <a:ext cx="164592" cy="164592"/>
+            <a:off x="2011680" y="2286000"/>
+            <a:ext cx="182880" cy="182880"/>
           </a:xfrm>
           <a:prstGeom prst="roundRect">
             <a:avLst/>
@@ -22309,8 +22309,8 @@
         </p:nvSpPr>
         <p:spPr>
           <a:xfrm>
-            <a:off x="1463040" y="2651760"/>
-            <a:ext cx="164592" cy="164592"/>
+            <a:off x="1463040" y="2743200"/>
+            <a:ext cx="182880" cy="182880"/>
           </a:xfrm>
           <a:prstGeom prst="roundRect">
             <a:avLst/>
@@ -22352,8 +22352,8 @@
         </p:nvSpPr>
         <p:spPr>
           <a:xfrm>
-            <a:off x="2194560" y="3200400"/>
-            <a:ext cx="164592" cy="164592"/>
+            <a:off x="1920240" y="3383280"/>
+            <a:ext cx="182880" cy="182880"/>
           </a:xfrm>
           <a:prstGeom prst="roundRect">
             <a:avLst/>
@@ -22395,8 +22395,8 @@
         </p:nvSpPr>
         <p:spPr>
           <a:xfrm>
-            <a:off x="1737360" y="3017520"/>
-            <a:ext cx="164592" cy="164592"/>
+            <a:off x="1737360" y="3566160"/>
+            <a:ext cx="182880" cy="182880"/>
           </a:xfrm>
           <a:prstGeom prst="roundRect">
             <a:avLst/>
@@ -22438,8 +22438,8 @@
         </p:nvSpPr>
         <p:spPr>
           <a:xfrm>
-            <a:off x="2560320" y="2743200"/>
-            <a:ext cx="164592" cy="164592"/>
+            <a:off x="2194560" y="2834640"/>
+            <a:ext cx="182880" cy="182880"/>
           </a:xfrm>
           <a:prstGeom prst="roundRect">
             <a:avLst/>
@@ -22481,8 +22481,8 @@
         </p:nvSpPr>
         <p:spPr>
           <a:xfrm>
-            <a:off x="2011680" y="3383280"/>
-            <a:ext cx="164592" cy="164592"/>
+            <a:off x="2103120" y="3749039"/>
+            <a:ext cx="182880" cy="182880"/>
           </a:xfrm>
           <a:prstGeom prst="roundRect">
             <a:avLst/>
@@ -22524,8 +22524,8 @@
         </p:nvSpPr>
         <p:spPr>
           <a:xfrm>
-            <a:off x="2468880" y="3108960"/>
-            <a:ext cx="164592" cy="164592"/>
+            <a:off x="1554480" y="3931920"/>
+            <a:ext cx="182880" cy="182880"/>
           </a:xfrm>
           <a:prstGeom prst="roundRect">
             <a:avLst/>
@@ -22567,8 +22567,8 @@
         </p:nvSpPr>
         <p:spPr>
           <a:xfrm>
-            <a:off x="3474720" y="2926080"/>
-            <a:ext cx="164592" cy="164592"/>
+            <a:off x="3657600" y="1920240"/>
+            <a:ext cx="182880" cy="182880"/>
           </a:xfrm>
           <a:prstGeom prst="roundRect">
             <a:avLst/>
@@ -22610,8 +22610,8 @@
         </p:nvSpPr>
         <p:spPr>
           <a:xfrm>
-            <a:off x="3931920" y="3383280"/>
-            <a:ext cx="164592" cy="164592"/>
+            <a:off x="3931920" y="2468880"/>
+            <a:ext cx="182880" cy="182880"/>
           </a:xfrm>
           <a:prstGeom prst="roundRect">
             <a:avLst/>
@@ -22653,8 +22653,8 @@
         </p:nvSpPr>
         <p:spPr>
           <a:xfrm>
-            <a:off x="3749039" y="3657600"/>
-            <a:ext cx="164592" cy="164592"/>
+            <a:off x="3749039" y="3017520"/>
+            <a:ext cx="182880" cy="182880"/>
           </a:xfrm>
           <a:prstGeom prst="roundRect">
             <a:avLst/>
@@ -22696,8 +22696,8 @@
         </p:nvSpPr>
         <p:spPr>
           <a:xfrm>
-            <a:off x="4114800" y="3200400"/>
-            <a:ext cx="164592" cy="164592"/>
+            <a:off x="4114800" y="2194560"/>
+            <a:ext cx="182880" cy="182880"/>
           </a:xfrm>
           <a:prstGeom prst="roundRect">
             <a:avLst/>
@@ -22739,8 +22739,8 @@
         </p:nvSpPr>
         <p:spPr>
           <a:xfrm>
-            <a:off x="3291840" y="3566160"/>
-            <a:ext cx="164592" cy="164592"/>
+            <a:off x="3566160" y="2743200"/>
+            <a:ext cx="182880" cy="182880"/>
           </a:xfrm>
           <a:prstGeom prst="roundRect">
             <a:avLst/>
@@ -22782,8 +22782,8 @@
         </p:nvSpPr>
         <p:spPr>
           <a:xfrm>
-            <a:off x="4023360" y="3840480"/>
-            <a:ext cx="164592" cy="164592"/>
+            <a:off x="4023360" y="3291840"/>
+            <a:ext cx="182880" cy="182880"/>
           </a:xfrm>
           <a:prstGeom prst="roundRect">
             <a:avLst/>
@@ -22825,8 +22825,8 @@
         </p:nvSpPr>
         <p:spPr>
           <a:xfrm>
-            <a:off x="3566160" y="3931920"/>
-            <a:ext cx="164592" cy="164592"/>
+            <a:off x="3840480" y="3566160"/>
+            <a:ext cx="182880" cy="182880"/>
           </a:xfrm>
           <a:prstGeom prst="roundRect">
             <a:avLst/>
@@ -22868,8 +22868,8 @@
         </p:nvSpPr>
         <p:spPr>
           <a:xfrm>
-            <a:off x="4389120" y="3566160"/>
-            <a:ext cx="164592" cy="164592"/>
+            <a:off x="4297680" y="2926080"/>
+            <a:ext cx="182880" cy="182880"/>
           </a:xfrm>
           <a:prstGeom prst="roundRect">
             <a:avLst/>
@@ -22911,8 +22911,8 @@
         </p:nvSpPr>
         <p:spPr>
           <a:xfrm>
-            <a:off x="3840480" y="4114800"/>
-            <a:ext cx="164592" cy="164592"/>
+            <a:off x="4206240" y="3749039"/>
+            <a:ext cx="182880" cy="182880"/>
           </a:xfrm>
           <a:prstGeom prst="roundRect">
             <a:avLst/>
@@ -22954,8 +22954,8 @@
         </p:nvSpPr>
         <p:spPr>
           <a:xfrm>
-            <a:off x="4206240" y="3840480"/>
-            <a:ext cx="164592" cy="164592"/>
+            <a:off x="3931920" y="4023360"/>
+            <a:ext cx="182880" cy="182880"/>
           </a:xfrm>
           <a:prstGeom prst="roundRect">
             <a:avLst/>
@@ -22997,8 +22997,8 @@
         </p:nvSpPr>
         <p:spPr>
           <a:xfrm>
-            <a:off x="2286000" y="1737360"/>
-            <a:ext cx="2743200" cy="36576"/>
+            <a:off x="2971800" y="1645920"/>
+            <a:ext cx="36576" cy="3657600"/>
           </a:xfrm>
           <a:prstGeom prst="rect">
             <a:avLst/>
@@ -23040,8 +23040,8 @@
         </p:nvSpPr>
         <p:spPr>
           <a:xfrm>
-            <a:off x="2011680" y="2194560"/>
-            <a:ext cx="2743200" cy="18288"/>
+            <a:off x="2514600" y="1645920"/>
+            <a:ext cx="18288" cy="3657600"/>
           </a:xfrm>
           <a:prstGeom prst="rect">
             <a:avLst/>
@@ -23083,8 +23083,8 @@
         </p:nvSpPr>
         <p:spPr>
           <a:xfrm>
-            <a:off x="2560320" y="1280160"/>
-            <a:ext cx="2743200" cy="18288"/>
+            <a:off x="3429000" y="1645920"/>
+            <a:ext cx="18288" cy="3657600"/>
           </a:xfrm>
           <a:prstGeom prst="rect">
             <a:avLst/>
@@ -23126,8 +23126,44 @@
         </p:nvSpPr>
         <p:spPr>
           <a:xfrm>
-            <a:off x="1371600" y="3931920"/>
-            <a:ext cx="1371600" cy="274320"/>
+            <a:off x="2377440" y="4572000"/>
+            <a:ext cx="1280160" cy="274320"/>
+          </a:xfrm>
+          <a:prstGeom prst="rect">
+            <a:avLst/>
+          </a:prstGeom>
+          <a:noFill/>
+        </p:spPr>
+        <p:txBody>
+          <a:bodyPr wrap="square">
+            <a:spAutoFit/>
+          </a:bodyPr>
+          <a:lstStyle/>
+          <a:p>
+            <a:pPr algn="ctr">
+              <a:defRPr sz="1000" b="0">
+                <a:solidFill>
+                  <a:srgbClr val="CCCCCC"/>
+                </a:solidFill>
+                <a:latin typeface="Calibri"/>
+              </a:defRPr>
+            </a:pPr>
+            <a:r>
+              <a:t>← margin →</a:t>
+            </a:r>
+          </a:p>
+        </p:txBody>
+      </p:sp>
+      <p:sp>
+        <p:nvSpPr>
+          <p:cNvPr id="36" name="TextBox 35"/>
+          <p:cNvSpPr txBox="1"/>
+          <p:nvPr/>
+        </p:nvSpPr>
+        <p:spPr>
+          <a:xfrm>
+            <a:off x="1371600" y="4892040"/>
+            <a:ext cx="1188720" cy="274320"/>
           </a:xfrm>
           <a:prstGeom prst="rect">
             <a:avLst/>
@@ -23156,14 +23192,14 @@
       </p:sp>
       <p:sp>
         <p:nvSpPr>
-          <p:cNvPr id="36" name="TextBox 35"/>
-          <p:cNvSpPr txBox="1"/>
-          <p:nvPr/>
-        </p:nvSpPr>
-        <p:spPr>
-          <a:xfrm>
-            <a:off x="2743200" y="3931920"/>
-            <a:ext cx="1371600" cy="274320"/>
+          <p:cNvPr id="37" name="TextBox 36"/>
+          <p:cNvSpPr txBox="1"/>
+          <p:nvPr/>
+        </p:nvSpPr>
+        <p:spPr>
+          <a:xfrm>
+            <a:off x="2651760" y="4892040"/>
+            <a:ext cx="1188720" cy="274320"/>
           </a:xfrm>
           <a:prstGeom prst="rect">
             <a:avLst/>
@@ -23192,14 +23228,14 @@
       </p:sp>
       <p:sp>
         <p:nvSpPr>
-          <p:cNvPr id="37" name="TextBox 36"/>
-          <p:cNvSpPr txBox="1"/>
-          <p:nvPr/>
-        </p:nvSpPr>
-        <p:spPr>
-          <a:xfrm>
-            <a:off x="3840480" y="3931920"/>
-            <a:ext cx="1828800" cy="274320"/>
+          <p:cNvPr id="38" name="TextBox 37"/>
+          <p:cNvSpPr txBox="1"/>
+          <p:nvPr/>
+        </p:nvSpPr>
+        <p:spPr>
+          <a:xfrm>
+            <a:off x="3931920" y="4892040"/>
+            <a:ext cx="1645920" cy="274320"/>
           </a:xfrm>
           <a:prstGeom prst="rect">
             <a:avLst/>
@@ -23221,43 +23257,7 @@
               </a:defRPr>
             </a:pPr>
             <a:r>
-              <a:t>— Decision boundary</a:t>
-            </a:r>
-          </a:p>
-        </p:txBody>
-      </p:sp>
-      <p:sp>
-        <p:nvSpPr>
-          <p:cNvPr id="38" name="TextBox 37"/>
-          <p:cNvSpPr txBox="1"/>
-          <p:nvPr/>
-        </p:nvSpPr>
-        <p:spPr>
-          <a:xfrm>
-            <a:off x="1371600" y="4297680"/>
-            <a:ext cx="4114800" cy="365760"/>
-          </a:xfrm>
-          <a:prstGeom prst="rect">
-            <a:avLst/>
-          </a:prstGeom>
-          <a:noFill/>
-        </p:spPr>
-        <p:txBody>
-          <a:bodyPr wrap="square">
-            <a:spAutoFit/>
-          </a:bodyPr>
-          <a:lstStyle/>
-          <a:p>
-            <a:pPr algn="l">
-              <a:defRPr sz="1100" b="0">
-                <a:solidFill>
-                  <a:srgbClr val="CCCCCC"/>
-                </a:solidFill>
-                <a:latin typeface="Calibri"/>
-              </a:defRPr>
-            </a:pPr>
-            <a:r>
-              <a:t>Margin = distance between boundary and nearest points</a:t>
+              <a:t>— Boundary</a:t>
             </a:r>
           </a:p>
         </p:txBody>

</xml_diff>